<commit_message>
Generate daily fund reports
</commit_message>
<xml_diff>
--- a/reports/2026-09-22.pptx
+++ b/reports/2026-09-22.pptx
@@ -3386,7 +3386,7 @@
                 </a:solidFill>
                 <a:latin typeface="Microsoft YaHei"/>
               </a:rPr>
-              <a:t>0.35%</a:t>
+              <a:t>1.10%</a:t>
             </a:r>
           </a:p>
         </p:txBody>
@@ -3529,11 +3529,11 @@
             <a:r>
               <a:rPr sz="2400" b="1">
                 <a:solidFill>
-                  <a:srgbClr val="BF4040"/>
-                </a:solidFill>
-                <a:latin typeface="Microsoft YaHei"/>
-              </a:rPr>
-              <a:t>-0.46%</a:t>
+                  <a:srgbClr val="198974"/>
+                </a:solidFill>
+                <a:latin typeface="Microsoft YaHei"/>
+              </a:rPr>
+              <a:t>0.26%</a:t>
             </a:r>
           </a:p>
         </p:txBody>
@@ -4236,7 +4236,7 @@
         <p:spPr>
           <a:xfrm>
             <a:off x="2423160" y="1792224"/>
-            <a:ext cx="905980" cy="146304"/>
+            <a:ext cx="62275" cy="146304"/>
           </a:xfrm>
           <a:prstGeom prst="rect">
             <a:avLst/>
@@ -4278,7 +4278,7 @@
         </p:nvSpPr>
         <p:spPr>
           <a:xfrm>
-            <a:off x="3374860" y="1746504"/>
+            <a:off x="2531155" y="1746504"/>
             <a:ext cx="502920" cy="201168"/>
           </a:xfrm>
           <a:prstGeom prst="rect">
@@ -4299,7 +4299,7 @@
                 </a:solidFill>
                 <a:latin typeface="Microsoft YaHei"/>
               </a:rPr>
-              <a:t>0.68%</a:t>
+              <a:t>0.13%</a:t>
             </a:r>
           </a:p>
         </p:txBody>
@@ -4389,8 +4389,162 @@
         </p:nvSpPr>
         <p:spPr>
           <a:xfrm>
-            <a:off x="2423160" y="2176272"/>
-            <a:ext cx="92163" cy="146304"/>
+            <a:off x="2404872" y="2176272"/>
+            <a:ext cx="18288" cy="146304"/>
+          </a:xfrm>
+          <a:prstGeom prst="rect">
+            <a:avLst/>
+          </a:prstGeom>
+          <a:solidFill>
+            <a:srgbClr val="BF4040"/>
+          </a:solidFill>
+          <a:ln>
+            <a:noFill/>
+          </a:ln>
+        </p:spPr>
+        <p:style>
+          <a:lnRef idx="1">
+            <a:schemeClr val="accent1"/>
+          </a:lnRef>
+          <a:fillRef idx="3">
+            <a:schemeClr val="accent1"/>
+          </a:fillRef>
+          <a:effectRef idx="2">
+            <a:schemeClr val="accent1"/>
+          </a:effectRef>
+          <a:fontRef idx="minor">
+            <a:schemeClr val="lt1"/>
+          </a:fontRef>
+        </p:style>
+        <p:txBody>
+          <a:bodyPr rtlCol="0" anchor="ctr"/>
+          <a:lstStyle/>
+          <a:p>
+            <a:pPr algn="ctr"/>
+          </a:p>
+        </p:txBody>
+      </p:sp>
+      <p:sp>
+        <p:nvSpPr>
+          <p:cNvPr id="13" name="TextBox 12"/>
+          <p:cNvSpPr txBox="1"/>
+          <p:nvPr/>
+        </p:nvSpPr>
+        <p:spPr>
+          <a:xfrm>
+            <a:off x="2468879" y="2130552"/>
+            <a:ext cx="502920" cy="201168"/>
+          </a:xfrm>
+          <a:prstGeom prst="rect">
+            <a:avLst/>
+          </a:prstGeom>
+          <a:noFill/>
+        </p:spPr>
+        <p:txBody>
+          <a:bodyPr wrap="none" lIns="18288" rIns="18288" tIns="18288" bIns="18288">
+            <a:spAutoFit/>
+          </a:bodyPr>
+          <a:lstStyle/>
+          <a:p>
+            <a:r>
+              <a:rPr sz="800" b="0">
+                <a:solidFill>
+                  <a:srgbClr val="1A2026"/>
+                </a:solidFill>
+                <a:latin typeface="Microsoft YaHei"/>
+              </a:rPr>
+              <a:t>-0.01%</a:t>
+            </a:r>
+          </a:p>
+        </p:txBody>
+      </p:sp>
+      <p:sp>
+        <p:nvSpPr>
+          <p:cNvPr id="14" name="TextBox 13"/>
+          <p:cNvSpPr txBox="1"/>
+          <p:nvPr/>
+        </p:nvSpPr>
+        <p:spPr>
+          <a:xfrm>
+            <a:off x="640080" y="2505456"/>
+            <a:ext cx="1078992" cy="201168"/>
+          </a:xfrm>
+          <a:prstGeom prst="rect">
+            <a:avLst/>
+          </a:prstGeom>
+          <a:noFill/>
+        </p:spPr>
+        <p:txBody>
+          <a:bodyPr wrap="none" lIns="18288" rIns="18288" tIns="18288" bIns="18288">
+            <a:spAutoFit/>
+          </a:bodyPr>
+          <a:lstStyle/>
+          <a:p>
+            <a:r>
+              <a:rPr sz="800" b="0">
+                <a:solidFill>
+                  <a:srgbClr val="65707D"/>
+                </a:solidFill>
+                <a:latin typeface="Microsoft YaHei"/>
+              </a:rPr>
+              <a:t>纳斯达克100指</a:t>
+            </a:r>
+          </a:p>
+        </p:txBody>
+      </p:sp>
+      <p:sp>
+        <p:nvSpPr>
+          <p:cNvPr id="15" name="Rectangle 14"/>
+          <p:cNvSpPr/>
+          <p:nvPr/>
+        </p:nvSpPr>
+        <p:spPr>
+          <a:xfrm>
+            <a:off x="2423160" y="2578608"/>
+            <a:ext cx="9144" cy="118872"/>
+          </a:xfrm>
+          <a:prstGeom prst="rect">
+            <a:avLst/>
+          </a:prstGeom>
+          <a:solidFill>
+            <a:srgbClr val="DAD5C9"/>
+          </a:solidFill>
+          <a:ln>
+            <a:noFill/>
+          </a:ln>
+        </p:spPr>
+        <p:style>
+          <a:lnRef idx="1">
+            <a:schemeClr val="accent1"/>
+          </a:lnRef>
+          <a:fillRef idx="3">
+            <a:schemeClr val="accent1"/>
+          </a:fillRef>
+          <a:effectRef idx="2">
+            <a:schemeClr val="accent1"/>
+          </a:effectRef>
+          <a:fontRef idx="minor">
+            <a:schemeClr val="lt1"/>
+          </a:fontRef>
+        </p:style>
+        <p:txBody>
+          <a:bodyPr rtlCol="0" anchor="ctr"/>
+          <a:lstStyle/>
+          <a:p>
+            <a:pPr algn="ctr"/>
+          </a:p>
+        </p:txBody>
+      </p:sp>
+      <p:sp>
+        <p:nvSpPr>
+          <p:cNvPr id="16" name="Rectangle 15"/>
+          <p:cNvSpPr/>
+          <p:nvPr/>
+        </p:nvSpPr>
+        <p:spPr>
+          <a:xfrm>
+            <a:off x="2423160" y="2560320"/>
+            <a:ext cx="1325880" cy="146304"/>
           </a:xfrm>
           <a:prstGeom prst="rect">
             <a:avLst/>
@@ -4426,13 +4580,13 @@
       </p:sp>
       <p:sp>
         <p:nvSpPr>
-          <p:cNvPr id="13" name="TextBox 12"/>
-          <p:cNvSpPr txBox="1"/>
-          <p:nvPr/>
-        </p:nvSpPr>
-        <p:spPr>
-          <a:xfrm>
-            <a:off x="2561043" y="2130552"/>
+          <p:cNvPr id="17" name="TextBox 16"/>
+          <p:cNvSpPr txBox="1"/>
+          <p:nvPr/>
+        </p:nvSpPr>
+        <p:spPr>
+          <a:xfrm>
+            <a:off x="3794759" y="2514600"/>
             <a:ext cx="502920" cy="201168"/>
           </a:xfrm>
           <a:prstGeom prst="rect">
@@ -4453,20 +4607,20 @@
                 </a:solidFill>
                 <a:latin typeface="Microsoft YaHei"/>
               </a:rPr>
-              <a:t>0.07%</a:t>
-            </a:r>
-          </a:p>
-        </p:txBody>
-      </p:sp>
-      <p:sp>
-        <p:nvSpPr>
-          <p:cNvPr id="14" name="TextBox 13"/>
-          <p:cNvSpPr txBox="1"/>
-          <p:nvPr/>
-        </p:nvSpPr>
-        <p:spPr>
-          <a:xfrm>
-            <a:off x="640080" y="2505456"/>
+              <a:t>2.69%</a:t>
+            </a:r>
+          </a:p>
+        </p:txBody>
+      </p:sp>
+      <p:sp>
+        <p:nvSpPr>
+          <p:cNvPr id="18" name="TextBox 17"/>
+          <p:cNvSpPr txBox="1"/>
+          <p:nvPr/>
+        </p:nvSpPr>
+        <p:spPr>
+          <a:xfrm>
+            <a:off x="640080" y="2889503"/>
             <a:ext cx="1078992" cy="201168"/>
           </a:xfrm>
           <a:prstGeom prst="rect">
@@ -4487,20 +4641,20 @@
                 </a:solidFill>
                 <a:latin typeface="Microsoft YaHei"/>
               </a:rPr>
-              <a:t>纳斯达克100指</a:t>
-            </a:r>
-          </a:p>
-        </p:txBody>
-      </p:sp>
-      <p:sp>
-        <p:nvSpPr>
-          <p:cNvPr id="15" name="Rectangle 14"/>
+              <a:t>兴全安泰积极养老</a:t>
+            </a:r>
+          </a:p>
+        </p:txBody>
+      </p:sp>
+      <p:sp>
+        <p:nvSpPr>
+          <p:cNvPr id="19" name="Rectangle 18"/>
           <p:cNvSpPr/>
           <p:nvPr/>
         </p:nvSpPr>
         <p:spPr>
           <a:xfrm>
-            <a:off x="2423160" y="2578608"/>
+            <a:off x="2423160" y="2962656"/>
             <a:ext cx="9144" cy="118872"/>
           </a:xfrm>
           <a:prstGeom prst="rect">
@@ -4537,14 +4691,14 @@
       </p:sp>
       <p:sp>
         <p:nvSpPr>
-          <p:cNvPr id="16" name="Rectangle 15"/>
+          <p:cNvPr id="20" name="Rectangle 19"/>
           <p:cNvSpPr/>
           <p:nvPr/>
         </p:nvSpPr>
         <p:spPr>
           <a:xfrm>
-            <a:off x="2423160" y="2560320"/>
-            <a:ext cx="643025" cy="146304"/>
+            <a:off x="2423160" y="2944368"/>
+            <a:ext cx="450540" cy="146304"/>
           </a:xfrm>
           <a:prstGeom prst="rect">
             <a:avLst/>
@@ -4580,13 +4734,13 @@
       </p:sp>
       <p:sp>
         <p:nvSpPr>
-          <p:cNvPr id="17" name="TextBox 16"/>
-          <p:cNvSpPr txBox="1"/>
-          <p:nvPr/>
-        </p:nvSpPr>
-        <p:spPr>
-          <a:xfrm>
-            <a:off x="3111905" y="2514600"/>
+          <p:cNvPr id="21" name="TextBox 20"/>
+          <p:cNvSpPr txBox="1"/>
+          <p:nvPr/>
+        </p:nvSpPr>
+        <p:spPr>
+          <a:xfrm>
+            <a:off x="2919420" y="2898648"/>
             <a:ext cx="502920" cy="201168"/>
           </a:xfrm>
           <a:prstGeom prst="rect">
@@ -4607,20 +4761,20 @@
                 </a:solidFill>
                 <a:latin typeface="Microsoft YaHei"/>
               </a:rPr>
-              <a:t>0.48%</a:t>
-            </a:r>
-          </a:p>
-        </p:txBody>
-      </p:sp>
-      <p:sp>
-        <p:nvSpPr>
-          <p:cNvPr id="18" name="TextBox 17"/>
-          <p:cNvSpPr txBox="1"/>
-          <p:nvPr/>
-        </p:nvSpPr>
-        <p:spPr>
-          <a:xfrm>
-            <a:off x="640080" y="2889503"/>
+              <a:t>0.92%</a:t>
+            </a:r>
+          </a:p>
+        </p:txBody>
+      </p:sp>
+      <p:sp>
+        <p:nvSpPr>
+          <p:cNvPr id="22" name="TextBox 21"/>
+          <p:cNvSpPr txBox="1"/>
+          <p:nvPr/>
+        </p:nvSpPr>
+        <p:spPr>
+          <a:xfrm>
+            <a:off x="640080" y="3273551"/>
             <a:ext cx="1078992" cy="201168"/>
           </a:xfrm>
           <a:prstGeom prst="rect">
@@ -4641,20 +4795,20 @@
                 </a:solidFill>
                 <a:latin typeface="Microsoft YaHei"/>
               </a:rPr>
-              <a:t>兴全安泰积极养老</a:t>
-            </a:r>
-          </a:p>
-        </p:txBody>
-      </p:sp>
-      <p:sp>
-        <p:nvSpPr>
-          <p:cNvPr id="19" name="Rectangle 18"/>
+              <a:t>易方达全球优质企</a:t>
+            </a:r>
+          </a:p>
+        </p:txBody>
+      </p:sp>
+      <p:sp>
+        <p:nvSpPr>
+          <p:cNvPr id="23" name="Rectangle 22"/>
           <p:cNvSpPr/>
           <p:nvPr/>
         </p:nvSpPr>
         <p:spPr>
           <a:xfrm>
-            <a:off x="2423160" y="2962656"/>
+            <a:off x="2423160" y="3346703"/>
             <a:ext cx="9144" cy="118872"/>
           </a:xfrm>
           <a:prstGeom prst="rect">
@@ -4691,14 +4845,356 @@
       </p:sp>
       <p:sp>
         <p:nvSpPr>
-          <p:cNvPr id="20" name="Rectangle 19"/>
+          <p:cNvPr id="24" name="Rectangle 23"/>
           <p:cNvSpPr/>
           <p:nvPr/>
         </p:nvSpPr>
         <p:spPr>
           <a:xfrm>
-            <a:off x="2206778" y="2944368"/>
-            <a:ext cx="216381" cy="146304"/>
+            <a:off x="2423160" y="3328415"/>
+            <a:ext cx="875774" cy="146304"/>
+          </a:xfrm>
+          <a:prstGeom prst="rect">
+            <a:avLst/>
+          </a:prstGeom>
+          <a:solidFill>
+            <a:srgbClr val="198974"/>
+          </a:solidFill>
+          <a:ln>
+            <a:noFill/>
+          </a:ln>
+        </p:spPr>
+        <p:style>
+          <a:lnRef idx="1">
+            <a:schemeClr val="accent1"/>
+          </a:lnRef>
+          <a:fillRef idx="3">
+            <a:schemeClr val="accent1"/>
+          </a:fillRef>
+          <a:effectRef idx="2">
+            <a:schemeClr val="accent1"/>
+          </a:effectRef>
+          <a:fontRef idx="minor">
+            <a:schemeClr val="lt1"/>
+          </a:fontRef>
+        </p:style>
+        <p:txBody>
+          <a:bodyPr rtlCol="0" anchor="ctr"/>
+          <a:lstStyle/>
+          <a:p>
+            <a:pPr algn="ctr"/>
+          </a:p>
+        </p:txBody>
+      </p:sp>
+      <p:sp>
+        <p:nvSpPr>
+          <p:cNvPr id="25" name="TextBox 24"/>
+          <p:cNvSpPr txBox="1"/>
+          <p:nvPr/>
+        </p:nvSpPr>
+        <p:spPr>
+          <a:xfrm>
+            <a:off x="3344654" y="3282696"/>
+            <a:ext cx="502920" cy="201168"/>
+          </a:xfrm>
+          <a:prstGeom prst="rect">
+            <a:avLst/>
+          </a:prstGeom>
+          <a:noFill/>
+        </p:spPr>
+        <p:txBody>
+          <a:bodyPr wrap="none" lIns="18288" rIns="18288" tIns="18288" bIns="18288">
+            <a:spAutoFit/>
+          </a:bodyPr>
+          <a:lstStyle/>
+          <a:p>
+            <a:r>
+              <a:rPr sz="800" b="0">
+                <a:solidFill>
+                  <a:srgbClr val="1A2026"/>
+                </a:solidFill>
+                <a:latin typeface="Microsoft YaHei"/>
+              </a:rPr>
+              <a:t>1.78%</a:t>
+            </a:r>
+          </a:p>
+        </p:txBody>
+      </p:sp>
+      <p:sp>
+        <p:nvSpPr>
+          <p:cNvPr id="26" name="TextBox 25"/>
+          <p:cNvSpPr txBox="1"/>
+          <p:nvPr/>
+        </p:nvSpPr>
+        <p:spPr>
+          <a:xfrm>
+            <a:off x="4251960" y="1371600"/>
+            <a:ext cx="3383280" cy="219456"/>
+          </a:xfrm>
+          <a:prstGeom prst="rect">
+            <a:avLst/>
+          </a:prstGeom>
+          <a:noFill/>
+        </p:spPr>
+        <p:txBody>
+          <a:bodyPr wrap="none" lIns="18288" rIns="18288" tIns="18288" bIns="18288">
+            <a:spAutoFit/>
+          </a:bodyPr>
+          <a:lstStyle/>
+          <a:p>
+            <a:r>
+              <a:rPr sz="1100" b="1">
+                <a:solidFill>
+                  <a:srgbClr val="1A2026"/>
+                </a:solidFill>
+                <a:latin typeface="Microsoft YaHei"/>
+              </a:rPr>
+              <a:t>近1周收益</a:t>
+            </a:r>
+          </a:p>
+        </p:txBody>
+      </p:sp>
+      <p:sp>
+        <p:nvSpPr>
+          <p:cNvPr id="27" name="TextBox 26"/>
+          <p:cNvSpPr txBox="1"/>
+          <p:nvPr/>
+        </p:nvSpPr>
+        <p:spPr>
+          <a:xfrm>
+            <a:off x="4251960" y="1737360"/>
+            <a:ext cx="1078992" cy="201168"/>
+          </a:xfrm>
+          <a:prstGeom prst="rect">
+            <a:avLst/>
+          </a:prstGeom>
+          <a:noFill/>
+        </p:spPr>
+        <p:txBody>
+          <a:bodyPr wrap="none" lIns="18288" rIns="18288" tIns="18288" bIns="18288">
+            <a:spAutoFit/>
+          </a:bodyPr>
+          <a:lstStyle/>
+          <a:p>
+            <a:r>
+              <a:rPr sz="800" b="0">
+                <a:solidFill>
+                  <a:srgbClr val="65707D"/>
+                </a:solidFill>
+                <a:latin typeface="Microsoft YaHei"/>
+              </a:rPr>
+              <a:t>华夏沪深300E</a:t>
+            </a:r>
+          </a:p>
+        </p:txBody>
+      </p:sp>
+      <p:sp>
+        <p:nvSpPr>
+          <p:cNvPr id="28" name="Rectangle 27"/>
+          <p:cNvSpPr/>
+          <p:nvPr/>
+        </p:nvSpPr>
+        <p:spPr>
+          <a:xfrm>
+            <a:off x="6035040" y="1810512"/>
+            <a:ext cx="9144" cy="118872"/>
+          </a:xfrm>
+          <a:prstGeom prst="rect">
+            <a:avLst/>
+          </a:prstGeom>
+          <a:solidFill>
+            <a:srgbClr val="DAD5C9"/>
+          </a:solidFill>
+          <a:ln>
+            <a:noFill/>
+          </a:ln>
+        </p:spPr>
+        <p:style>
+          <a:lnRef idx="1">
+            <a:schemeClr val="accent1"/>
+          </a:lnRef>
+          <a:fillRef idx="3">
+            <a:schemeClr val="accent1"/>
+          </a:fillRef>
+          <a:effectRef idx="2">
+            <a:schemeClr val="accent1"/>
+          </a:effectRef>
+          <a:fontRef idx="minor">
+            <a:schemeClr val="lt1"/>
+          </a:fontRef>
+        </p:style>
+        <p:txBody>
+          <a:bodyPr rtlCol="0" anchor="ctr"/>
+          <a:lstStyle/>
+          <a:p>
+            <a:pPr algn="ctr"/>
+          </a:p>
+        </p:txBody>
+      </p:sp>
+      <p:sp>
+        <p:nvSpPr>
+          <p:cNvPr id="29" name="Rectangle 28"/>
+          <p:cNvSpPr/>
+          <p:nvPr/>
+        </p:nvSpPr>
+        <p:spPr>
+          <a:xfrm>
+            <a:off x="6035040" y="1792224"/>
+            <a:ext cx="654535" cy="146304"/>
+          </a:xfrm>
+          <a:prstGeom prst="rect">
+            <a:avLst/>
+          </a:prstGeom>
+          <a:solidFill>
+            <a:srgbClr val="198974"/>
+          </a:solidFill>
+          <a:ln>
+            <a:noFill/>
+          </a:ln>
+        </p:spPr>
+        <p:style>
+          <a:lnRef idx="1">
+            <a:schemeClr val="accent1"/>
+          </a:lnRef>
+          <a:fillRef idx="3">
+            <a:schemeClr val="accent1"/>
+          </a:fillRef>
+          <a:effectRef idx="2">
+            <a:schemeClr val="accent1"/>
+          </a:effectRef>
+          <a:fontRef idx="minor">
+            <a:schemeClr val="lt1"/>
+          </a:fontRef>
+        </p:style>
+        <p:txBody>
+          <a:bodyPr rtlCol="0" anchor="ctr"/>
+          <a:lstStyle/>
+          <a:p>
+            <a:pPr algn="ctr"/>
+          </a:p>
+        </p:txBody>
+      </p:sp>
+      <p:sp>
+        <p:nvSpPr>
+          <p:cNvPr id="30" name="TextBox 29"/>
+          <p:cNvSpPr txBox="1"/>
+          <p:nvPr/>
+        </p:nvSpPr>
+        <p:spPr>
+          <a:xfrm>
+            <a:off x="6735295" y="1746504"/>
+            <a:ext cx="502920" cy="201168"/>
+          </a:xfrm>
+          <a:prstGeom prst="rect">
+            <a:avLst/>
+          </a:prstGeom>
+          <a:noFill/>
+        </p:spPr>
+        <p:txBody>
+          <a:bodyPr wrap="none" lIns="18288" rIns="18288" tIns="18288" bIns="18288">
+            <a:spAutoFit/>
+          </a:bodyPr>
+          <a:lstStyle/>
+          <a:p>
+            <a:r>
+              <a:rPr sz="800" b="0">
+                <a:solidFill>
+                  <a:srgbClr val="1A2026"/>
+                </a:solidFill>
+                <a:latin typeface="Microsoft YaHei"/>
+              </a:rPr>
+              <a:t>2.11%</a:t>
+            </a:r>
+          </a:p>
+        </p:txBody>
+      </p:sp>
+      <p:sp>
+        <p:nvSpPr>
+          <p:cNvPr id="31" name="TextBox 30"/>
+          <p:cNvSpPr txBox="1"/>
+          <p:nvPr/>
+        </p:nvSpPr>
+        <p:spPr>
+          <a:xfrm>
+            <a:off x="4251960" y="2121408"/>
+            <a:ext cx="1078992" cy="201168"/>
+          </a:xfrm>
+          <a:prstGeom prst="rect">
+            <a:avLst/>
+          </a:prstGeom>
+          <a:noFill/>
+        </p:spPr>
+        <p:txBody>
+          <a:bodyPr wrap="none" lIns="18288" rIns="18288" tIns="18288" bIns="18288">
+            <a:spAutoFit/>
+          </a:bodyPr>
+          <a:lstStyle/>
+          <a:p>
+            <a:r>
+              <a:rPr sz="800" b="0">
+                <a:solidFill>
+                  <a:srgbClr val="65707D"/>
+                </a:solidFill>
+                <a:latin typeface="Microsoft YaHei"/>
+              </a:rPr>
+              <a:t>富国红利精选QD</a:t>
+            </a:r>
+          </a:p>
+        </p:txBody>
+      </p:sp>
+      <p:sp>
+        <p:nvSpPr>
+          <p:cNvPr id="32" name="Rectangle 31"/>
+          <p:cNvSpPr/>
+          <p:nvPr/>
+        </p:nvSpPr>
+        <p:spPr>
+          <a:xfrm>
+            <a:off x="6035040" y="2194560"/>
+            <a:ext cx="9144" cy="118872"/>
+          </a:xfrm>
+          <a:prstGeom prst="rect">
+            <a:avLst/>
+          </a:prstGeom>
+          <a:solidFill>
+            <a:srgbClr val="DAD5C9"/>
+          </a:solidFill>
+          <a:ln>
+            <a:noFill/>
+          </a:ln>
+        </p:spPr>
+        <p:style>
+          <a:lnRef idx="1">
+            <a:schemeClr val="accent1"/>
+          </a:lnRef>
+          <a:fillRef idx="3">
+            <a:schemeClr val="accent1"/>
+          </a:fillRef>
+          <a:effectRef idx="2">
+            <a:schemeClr val="accent1"/>
+          </a:effectRef>
+          <a:fontRef idx="minor">
+            <a:schemeClr val="lt1"/>
+          </a:fontRef>
+        </p:style>
+        <p:txBody>
+          <a:bodyPr rtlCol="0" anchor="ctr"/>
+          <a:lstStyle/>
+          <a:p>
+            <a:pPr algn="ctr"/>
+          </a:p>
+        </p:txBody>
+      </p:sp>
+      <p:sp>
+        <p:nvSpPr>
+          <p:cNvPr id="33" name="Rectangle 32"/>
+          <p:cNvSpPr/>
+          <p:nvPr/>
+        </p:nvSpPr>
+        <p:spPr>
+          <a:xfrm>
+            <a:off x="5738874" y="2176272"/>
+            <a:ext cx="296165" cy="146304"/>
           </a:xfrm>
           <a:prstGeom prst="rect">
             <a:avLst/>
@@ -4734,13 +5230,13 @@
       </p:sp>
       <p:sp>
         <p:nvSpPr>
-          <p:cNvPr id="21" name="TextBox 20"/>
-          <p:cNvSpPr txBox="1"/>
-          <p:nvPr/>
-        </p:nvSpPr>
-        <p:spPr>
-          <a:xfrm>
-            <a:off x="2468879" y="2898648"/>
+          <p:cNvPr id="34" name="TextBox 33"/>
+          <p:cNvSpPr txBox="1"/>
+          <p:nvPr/>
+        </p:nvSpPr>
+        <p:spPr>
+          <a:xfrm>
+            <a:off x="6080760" y="2130552"/>
             <a:ext cx="502920" cy="201168"/>
           </a:xfrm>
           <a:prstGeom prst="rect">
@@ -4761,20 +5257,20 @@
                 </a:solidFill>
                 <a:latin typeface="Microsoft YaHei"/>
               </a:rPr>
-              <a:t>-0.16%</a:t>
-            </a:r>
-          </a:p>
-        </p:txBody>
-      </p:sp>
-      <p:sp>
-        <p:nvSpPr>
-          <p:cNvPr id="22" name="TextBox 21"/>
-          <p:cNvSpPr txBox="1"/>
-          <p:nvPr/>
-        </p:nvSpPr>
-        <p:spPr>
-          <a:xfrm>
-            <a:off x="640080" y="3273551"/>
+              <a:t>-0.95%</a:t>
+            </a:r>
+          </a:p>
+        </p:txBody>
+      </p:sp>
+      <p:sp>
+        <p:nvSpPr>
+          <p:cNvPr id="35" name="TextBox 34"/>
+          <p:cNvSpPr txBox="1"/>
+          <p:nvPr/>
+        </p:nvSpPr>
+        <p:spPr>
+          <a:xfrm>
+            <a:off x="4251960" y="2505456"/>
             <a:ext cx="1078992" cy="201168"/>
           </a:xfrm>
           <a:prstGeom prst="rect">
@@ -4795,20 +5291,20 @@
                 </a:solidFill>
                 <a:latin typeface="Microsoft YaHei"/>
               </a:rPr>
-              <a:t>易方达全球优质企</a:t>
-            </a:r>
-          </a:p>
-        </p:txBody>
-      </p:sp>
-      <p:sp>
-        <p:nvSpPr>
-          <p:cNvPr id="23" name="Rectangle 22"/>
+              <a:t>纳斯达克100指</a:t>
+            </a:r>
+          </a:p>
+        </p:txBody>
+      </p:sp>
+      <p:sp>
+        <p:nvSpPr>
+          <p:cNvPr id="36" name="Rectangle 35"/>
           <p:cNvSpPr/>
           <p:nvPr/>
         </p:nvSpPr>
         <p:spPr>
           <a:xfrm>
-            <a:off x="2423160" y="3346703"/>
+            <a:off x="6035040" y="2578608"/>
             <a:ext cx="9144" cy="118872"/>
           </a:xfrm>
           <a:prstGeom prst="rect">
@@ -4845,14 +5341,14 @@
       </p:sp>
       <p:sp>
         <p:nvSpPr>
-          <p:cNvPr id="24" name="Rectangle 23"/>
+          <p:cNvPr id="37" name="Rectangle 36"/>
           <p:cNvSpPr/>
           <p:nvPr/>
         </p:nvSpPr>
         <p:spPr>
           <a:xfrm>
-            <a:off x="2423160" y="3328415"/>
-            <a:ext cx="898202" cy="146304"/>
+            <a:off x="6035040" y="2560320"/>
+            <a:ext cx="1325880" cy="146304"/>
           </a:xfrm>
           <a:prstGeom prst="rect">
             <a:avLst/>
@@ -4888,13 +5384,13 @@
       </p:sp>
       <p:sp>
         <p:nvSpPr>
-          <p:cNvPr id="25" name="TextBox 24"/>
-          <p:cNvSpPr txBox="1"/>
-          <p:nvPr/>
-        </p:nvSpPr>
-        <p:spPr>
-          <a:xfrm>
-            <a:off x="3367082" y="3282696"/>
+          <p:cNvPr id="38" name="TextBox 37"/>
+          <p:cNvSpPr txBox="1"/>
+          <p:nvPr/>
+        </p:nvSpPr>
+        <p:spPr>
+          <a:xfrm>
+            <a:off x="7406640" y="2514600"/>
             <a:ext cx="502920" cy="201168"/>
           </a:xfrm>
           <a:prstGeom prst="rect">
@@ -4915,54 +5411,20 @@
                 </a:solidFill>
                 <a:latin typeface="Microsoft YaHei"/>
               </a:rPr>
-              <a:t>0.68%</a:t>
-            </a:r>
-          </a:p>
-        </p:txBody>
-      </p:sp>
-      <p:sp>
-        <p:nvSpPr>
-          <p:cNvPr id="26" name="TextBox 25"/>
-          <p:cNvSpPr txBox="1"/>
-          <p:nvPr/>
-        </p:nvSpPr>
-        <p:spPr>
-          <a:xfrm>
-            <a:off x="4251960" y="1371600"/>
-            <a:ext cx="3383280" cy="219456"/>
-          </a:xfrm>
-          <a:prstGeom prst="rect">
-            <a:avLst/>
-          </a:prstGeom>
-          <a:noFill/>
-        </p:spPr>
-        <p:txBody>
-          <a:bodyPr wrap="none" lIns="18288" rIns="18288" tIns="18288" bIns="18288">
-            <a:spAutoFit/>
-          </a:bodyPr>
-          <a:lstStyle/>
-          <a:p>
-            <a:r>
-              <a:rPr sz="1100" b="1">
-                <a:solidFill>
-                  <a:srgbClr val="1A2026"/>
-                </a:solidFill>
-                <a:latin typeface="Microsoft YaHei"/>
-              </a:rPr>
-              <a:t>近1周收益</a:t>
-            </a:r>
-          </a:p>
-        </p:txBody>
-      </p:sp>
-      <p:sp>
-        <p:nvSpPr>
-          <p:cNvPr id="27" name="TextBox 26"/>
-          <p:cNvSpPr txBox="1"/>
-          <p:nvPr/>
-        </p:nvSpPr>
-        <p:spPr>
-          <a:xfrm>
-            <a:off x="4251960" y="1737360"/>
+              <a:t>4.27%</a:t>
+            </a:r>
+          </a:p>
+        </p:txBody>
+      </p:sp>
+      <p:sp>
+        <p:nvSpPr>
+          <p:cNvPr id="39" name="TextBox 38"/>
+          <p:cNvSpPr txBox="1"/>
+          <p:nvPr/>
+        </p:nvSpPr>
+        <p:spPr>
+          <a:xfrm>
+            <a:off x="4251960" y="2889503"/>
             <a:ext cx="1078992" cy="201168"/>
           </a:xfrm>
           <a:prstGeom prst="rect">
@@ -4983,20 +5445,20 @@
                 </a:solidFill>
                 <a:latin typeface="Microsoft YaHei"/>
               </a:rPr>
-              <a:t>华夏沪深300E</a:t>
-            </a:r>
-          </a:p>
-        </p:txBody>
-      </p:sp>
-      <p:sp>
-        <p:nvSpPr>
-          <p:cNvPr id="28" name="Rectangle 27"/>
+              <a:t>兴全安泰积极养老</a:t>
+            </a:r>
+          </a:p>
+        </p:txBody>
+      </p:sp>
+      <p:sp>
+        <p:nvSpPr>
+          <p:cNvPr id="40" name="Rectangle 39"/>
           <p:cNvSpPr/>
           <p:nvPr/>
         </p:nvSpPr>
         <p:spPr>
           <a:xfrm>
-            <a:off x="6035040" y="1810512"/>
+            <a:off x="6035040" y="2962656"/>
             <a:ext cx="9144" cy="118872"/>
           </a:xfrm>
           <a:prstGeom prst="rect">
@@ -5033,14 +5495,14 @@
       </p:sp>
       <p:sp>
         <p:nvSpPr>
-          <p:cNvPr id="29" name="Rectangle 28"/>
+          <p:cNvPr id="41" name="Rectangle 40"/>
           <p:cNvSpPr/>
           <p:nvPr/>
         </p:nvSpPr>
         <p:spPr>
           <a:xfrm>
-            <a:off x="6035040" y="1792224"/>
-            <a:ext cx="1325880" cy="146304"/>
+            <a:off x="6035040" y="2944368"/>
+            <a:ext cx="246149" cy="146304"/>
           </a:xfrm>
           <a:prstGeom prst="rect">
             <a:avLst/>
@@ -5076,13 +5538,13 @@
       </p:sp>
       <p:sp>
         <p:nvSpPr>
-          <p:cNvPr id="30" name="TextBox 29"/>
-          <p:cNvSpPr txBox="1"/>
-          <p:nvPr/>
-        </p:nvSpPr>
-        <p:spPr>
-          <a:xfrm>
-            <a:off x="7406640" y="1746504"/>
+          <p:cNvPr id="42" name="TextBox 41"/>
+          <p:cNvSpPr txBox="1"/>
+          <p:nvPr/>
+        </p:nvSpPr>
+        <p:spPr>
+          <a:xfrm>
+            <a:off x="6326909" y="2898648"/>
             <a:ext cx="502920" cy="201168"/>
           </a:xfrm>
           <a:prstGeom prst="rect">
@@ -5103,20 +5565,20 @@
                 </a:solidFill>
                 <a:latin typeface="Microsoft YaHei"/>
               </a:rPr>
-              <a:t>1.34%</a:t>
-            </a:r>
-          </a:p>
-        </p:txBody>
-      </p:sp>
-      <p:sp>
-        <p:nvSpPr>
-          <p:cNvPr id="31" name="TextBox 30"/>
-          <p:cNvSpPr txBox="1"/>
-          <p:nvPr/>
-        </p:nvSpPr>
-        <p:spPr>
-          <a:xfrm>
-            <a:off x="4251960" y="2121408"/>
+              <a:t>0.79%</a:t>
+            </a:r>
+          </a:p>
+        </p:txBody>
+      </p:sp>
+      <p:sp>
+        <p:nvSpPr>
+          <p:cNvPr id="43" name="TextBox 42"/>
+          <p:cNvSpPr txBox="1"/>
+          <p:nvPr/>
+        </p:nvSpPr>
+        <p:spPr>
+          <a:xfrm>
+            <a:off x="4251960" y="3273551"/>
             <a:ext cx="1078992" cy="201168"/>
           </a:xfrm>
           <a:prstGeom prst="rect">
@@ -5137,20 +5599,20 @@
                 </a:solidFill>
                 <a:latin typeface="Microsoft YaHei"/>
               </a:rPr>
-              <a:t>富国红利精选QD</a:t>
-            </a:r>
-          </a:p>
-        </p:txBody>
-      </p:sp>
-      <p:sp>
-        <p:nvSpPr>
-          <p:cNvPr id="32" name="Rectangle 31"/>
+              <a:t>易方达全球优质企</a:t>
+            </a:r>
+          </a:p>
+        </p:txBody>
+      </p:sp>
+      <p:sp>
+        <p:nvSpPr>
+          <p:cNvPr id="44" name="Rectangle 43"/>
           <p:cNvSpPr/>
           <p:nvPr/>
         </p:nvSpPr>
         <p:spPr>
           <a:xfrm>
-            <a:off x="6035040" y="2194560"/>
+            <a:off x="6035040" y="3346703"/>
             <a:ext cx="9144" cy="118872"/>
           </a:xfrm>
           <a:prstGeom prst="rect">
@@ -5187,14 +5649,202 @@
       </p:sp>
       <p:sp>
         <p:nvSpPr>
-          <p:cNvPr id="33" name="Rectangle 32"/>
+          <p:cNvPr id="45" name="Rectangle 44"/>
           <p:cNvSpPr/>
           <p:nvPr/>
         </p:nvSpPr>
         <p:spPr>
           <a:xfrm>
-            <a:off x="4798207" y="2176272"/>
-            <a:ext cx="1236832" cy="146304"/>
+            <a:off x="6035040" y="3328415"/>
+            <a:ext cx="934584" cy="146304"/>
+          </a:xfrm>
+          <a:prstGeom prst="rect">
+            <a:avLst/>
+          </a:prstGeom>
+          <a:solidFill>
+            <a:srgbClr val="198974"/>
+          </a:solidFill>
+          <a:ln>
+            <a:noFill/>
+          </a:ln>
+        </p:spPr>
+        <p:style>
+          <a:lnRef idx="1">
+            <a:schemeClr val="accent1"/>
+          </a:lnRef>
+          <a:fillRef idx="3">
+            <a:schemeClr val="accent1"/>
+          </a:fillRef>
+          <a:effectRef idx="2">
+            <a:schemeClr val="accent1"/>
+          </a:effectRef>
+          <a:fontRef idx="minor">
+            <a:schemeClr val="lt1"/>
+          </a:fontRef>
+        </p:style>
+        <p:txBody>
+          <a:bodyPr rtlCol="0" anchor="ctr"/>
+          <a:lstStyle/>
+          <a:p>
+            <a:pPr algn="ctr"/>
+          </a:p>
+        </p:txBody>
+      </p:sp>
+      <p:sp>
+        <p:nvSpPr>
+          <p:cNvPr id="46" name="TextBox 45"/>
+          <p:cNvSpPr txBox="1"/>
+          <p:nvPr/>
+        </p:nvSpPr>
+        <p:spPr>
+          <a:xfrm>
+            <a:off x="7015344" y="3282696"/>
+            <a:ext cx="502920" cy="201168"/>
+          </a:xfrm>
+          <a:prstGeom prst="rect">
+            <a:avLst/>
+          </a:prstGeom>
+          <a:noFill/>
+        </p:spPr>
+        <p:txBody>
+          <a:bodyPr wrap="none" lIns="18288" rIns="18288" tIns="18288" bIns="18288">
+            <a:spAutoFit/>
+          </a:bodyPr>
+          <a:lstStyle/>
+          <a:p>
+            <a:r>
+              <a:rPr sz="800" b="0">
+                <a:solidFill>
+                  <a:srgbClr val="1A2026"/>
+                </a:solidFill>
+                <a:latin typeface="Microsoft YaHei"/>
+              </a:rPr>
+              <a:t>3.01%</a:t>
+            </a:r>
+          </a:p>
+        </p:txBody>
+      </p:sp>
+      <p:sp>
+        <p:nvSpPr>
+          <p:cNvPr id="47" name="TextBox 46"/>
+          <p:cNvSpPr txBox="1"/>
+          <p:nvPr/>
+        </p:nvSpPr>
+        <p:spPr>
+          <a:xfrm>
+            <a:off x="7863840" y="1371600"/>
+            <a:ext cx="3383280" cy="219456"/>
+          </a:xfrm>
+          <a:prstGeom prst="rect">
+            <a:avLst/>
+          </a:prstGeom>
+          <a:noFill/>
+        </p:spPr>
+        <p:txBody>
+          <a:bodyPr wrap="none" lIns="18288" rIns="18288" tIns="18288" bIns="18288">
+            <a:spAutoFit/>
+          </a:bodyPr>
+          <a:lstStyle/>
+          <a:p>
+            <a:r>
+              <a:rPr sz="1100" b="1">
+                <a:solidFill>
+                  <a:srgbClr val="1A2026"/>
+                </a:solidFill>
+                <a:latin typeface="Microsoft YaHei"/>
+              </a:rPr>
+              <a:t>近1个月收益</a:t>
+            </a:r>
+          </a:p>
+        </p:txBody>
+      </p:sp>
+      <p:sp>
+        <p:nvSpPr>
+          <p:cNvPr id="48" name="TextBox 47"/>
+          <p:cNvSpPr txBox="1"/>
+          <p:nvPr/>
+        </p:nvSpPr>
+        <p:spPr>
+          <a:xfrm>
+            <a:off x="7863840" y="1737360"/>
+            <a:ext cx="1078992" cy="201168"/>
+          </a:xfrm>
+          <a:prstGeom prst="rect">
+            <a:avLst/>
+          </a:prstGeom>
+          <a:noFill/>
+        </p:spPr>
+        <p:txBody>
+          <a:bodyPr wrap="none" lIns="18288" rIns="18288" tIns="18288" bIns="18288">
+            <a:spAutoFit/>
+          </a:bodyPr>
+          <a:lstStyle/>
+          <a:p>
+            <a:r>
+              <a:rPr sz="800" b="0">
+                <a:solidFill>
+                  <a:srgbClr val="65707D"/>
+                </a:solidFill>
+                <a:latin typeface="Microsoft YaHei"/>
+              </a:rPr>
+              <a:t>华夏沪深300E</a:t>
+            </a:r>
+          </a:p>
+        </p:txBody>
+      </p:sp>
+      <p:sp>
+        <p:nvSpPr>
+          <p:cNvPr id="49" name="Rectangle 48"/>
+          <p:cNvSpPr/>
+          <p:nvPr/>
+        </p:nvSpPr>
+        <p:spPr>
+          <a:xfrm>
+            <a:off x="9646919" y="1810512"/>
+            <a:ext cx="9144" cy="118872"/>
+          </a:xfrm>
+          <a:prstGeom prst="rect">
+            <a:avLst/>
+          </a:prstGeom>
+          <a:solidFill>
+            <a:srgbClr val="DAD5C9"/>
+          </a:solidFill>
+          <a:ln>
+            <a:noFill/>
+          </a:ln>
+        </p:spPr>
+        <p:style>
+          <a:lnRef idx="1">
+            <a:schemeClr val="accent1"/>
+          </a:lnRef>
+          <a:fillRef idx="3">
+            <a:schemeClr val="accent1"/>
+          </a:fillRef>
+          <a:effectRef idx="2">
+            <a:schemeClr val="accent1"/>
+          </a:effectRef>
+          <a:fontRef idx="minor">
+            <a:schemeClr val="lt1"/>
+          </a:fontRef>
+        </p:style>
+        <p:txBody>
+          <a:bodyPr rtlCol="0" anchor="ctr"/>
+          <a:lstStyle/>
+          <a:p>
+            <a:pPr algn="ctr"/>
+          </a:p>
+        </p:txBody>
+      </p:sp>
+      <p:sp>
+        <p:nvSpPr>
+          <p:cNvPr id="50" name="Rectangle 49"/>
+          <p:cNvSpPr/>
+          <p:nvPr/>
+        </p:nvSpPr>
+        <p:spPr>
+          <a:xfrm>
+            <a:off x="9591113" y="1792224"/>
+            <a:ext cx="55806" cy="146304"/>
           </a:xfrm>
           <a:prstGeom prst="rect">
             <a:avLst/>
@@ -5230,13 +5880,13 @@
       </p:sp>
       <p:sp>
         <p:nvSpPr>
-          <p:cNvPr id="34" name="TextBox 33"/>
-          <p:cNvSpPr txBox="1"/>
-          <p:nvPr/>
-        </p:nvSpPr>
-        <p:spPr>
-          <a:xfrm>
-            <a:off x="6080760" y="2130552"/>
+          <p:cNvPr id="51" name="TextBox 50"/>
+          <p:cNvSpPr txBox="1"/>
+          <p:nvPr/>
+        </p:nvSpPr>
+        <p:spPr>
+          <a:xfrm>
+            <a:off x="9692640" y="1746504"/>
             <a:ext cx="502920" cy="201168"/>
           </a:xfrm>
           <a:prstGeom prst="rect">
@@ -5257,20 +5907,20 @@
                 </a:solidFill>
                 <a:latin typeface="Microsoft YaHei"/>
               </a:rPr>
-              <a:t>-1.25%</a:t>
-            </a:r>
-          </a:p>
-        </p:txBody>
-      </p:sp>
-      <p:sp>
-        <p:nvSpPr>
-          <p:cNvPr id="35" name="TextBox 34"/>
-          <p:cNvSpPr txBox="1"/>
-          <p:nvPr/>
-        </p:nvSpPr>
-        <p:spPr>
-          <a:xfrm>
-            <a:off x="4251960" y="2505456"/>
+              <a:t>-0.14%</a:t>
+            </a:r>
+          </a:p>
+        </p:txBody>
+      </p:sp>
+      <p:sp>
+        <p:nvSpPr>
+          <p:cNvPr id="52" name="TextBox 51"/>
+          <p:cNvSpPr txBox="1"/>
+          <p:nvPr/>
+        </p:nvSpPr>
+        <p:spPr>
+          <a:xfrm>
+            <a:off x="7863840" y="2121408"/>
             <a:ext cx="1078992" cy="201168"/>
           </a:xfrm>
           <a:prstGeom prst="rect">
@@ -5291,20 +5941,20 @@
                 </a:solidFill>
                 <a:latin typeface="Microsoft YaHei"/>
               </a:rPr>
-              <a:t>纳斯达克100指</a:t>
-            </a:r>
-          </a:p>
-        </p:txBody>
-      </p:sp>
-      <p:sp>
-        <p:nvSpPr>
-          <p:cNvPr id="36" name="Rectangle 35"/>
+              <a:t>富国红利精选QD</a:t>
+            </a:r>
+          </a:p>
+        </p:txBody>
+      </p:sp>
+      <p:sp>
+        <p:nvSpPr>
+          <p:cNvPr id="53" name="Rectangle 52"/>
           <p:cNvSpPr/>
           <p:nvPr/>
         </p:nvSpPr>
         <p:spPr>
           <a:xfrm>
-            <a:off x="6035040" y="2578608"/>
+            <a:off x="9646919" y="2194560"/>
             <a:ext cx="9144" cy="118872"/>
           </a:xfrm>
           <a:prstGeom prst="rect">
@@ -5341,14 +5991,168 @@
       </p:sp>
       <p:sp>
         <p:nvSpPr>
-          <p:cNvPr id="37" name="Rectangle 36"/>
+          <p:cNvPr id="54" name="Rectangle 53"/>
           <p:cNvSpPr/>
           <p:nvPr/>
         </p:nvSpPr>
         <p:spPr>
           <a:xfrm>
-            <a:off x="6035040" y="2560320"/>
-            <a:ext cx="696547" cy="146304"/>
+            <a:off x="9337444" y="2176272"/>
+            <a:ext cx="309475" cy="146304"/>
+          </a:xfrm>
+          <a:prstGeom prst="rect">
+            <a:avLst/>
+          </a:prstGeom>
+          <a:solidFill>
+            <a:srgbClr val="BF4040"/>
+          </a:solidFill>
+          <a:ln>
+            <a:noFill/>
+          </a:ln>
+        </p:spPr>
+        <p:style>
+          <a:lnRef idx="1">
+            <a:schemeClr val="accent1"/>
+          </a:lnRef>
+          <a:fillRef idx="3">
+            <a:schemeClr val="accent1"/>
+          </a:fillRef>
+          <a:effectRef idx="2">
+            <a:schemeClr val="accent1"/>
+          </a:effectRef>
+          <a:fontRef idx="minor">
+            <a:schemeClr val="lt1"/>
+          </a:fontRef>
+        </p:style>
+        <p:txBody>
+          <a:bodyPr rtlCol="0" anchor="ctr"/>
+          <a:lstStyle/>
+          <a:p>
+            <a:pPr algn="ctr"/>
+          </a:p>
+        </p:txBody>
+      </p:sp>
+      <p:sp>
+        <p:nvSpPr>
+          <p:cNvPr id="55" name="TextBox 54"/>
+          <p:cNvSpPr txBox="1"/>
+          <p:nvPr/>
+        </p:nvSpPr>
+        <p:spPr>
+          <a:xfrm>
+            <a:off x="9692640" y="2130552"/>
+            <a:ext cx="502920" cy="201168"/>
+          </a:xfrm>
+          <a:prstGeom prst="rect">
+            <a:avLst/>
+          </a:prstGeom>
+          <a:noFill/>
+        </p:spPr>
+        <p:txBody>
+          <a:bodyPr wrap="none" lIns="18288" rIns="18288" tIns="18288" bIns="18288">
+            <a:spAutoFit/>
+          </a:bodyPr>
+          <a:lstStyle/>
+          <a:p>
+            <a:r>
+              <a:rPr sz="800" b="0">
+                <a:solidFill>
+                  <a:srgbClr val="1A2026"/>
+                </a:solidFill>
+                <a:latin typeface="Microsoft YaHei"/>
+              </a:rPr>
+              <a:t>-0.80%</a:t>
+            </a:r>
+          </a:p>
+        </p:txBody>
+      </p:sp>
+      <p:sp>
+        <p:nvSpPr>
+          <p:cNvPr id="56" name="TextBox 55"/>
+          <p:cNvSpPr txBox="1"/>
+          <p:nvPr/>
+        </p:nvSpPr>
+        <p:spPr>
+          <a:xfrm>
+            <a:off x="7863840" y="2505456"/>
+            <a:ext cx="1078992" cy="201168"/>
+          </a:xfrm>
+          <a:prstGeom prst="rect">
+            <a:avLst/>
+          </a:prstGeom>
+          <a:noFill/>
+        </p:spPr>
+        <p:txBody>
+          <a:bodyPr wrap="none" lIns="18288" rIns="18288" tIns="18288" bIns="18288">
+            <a:spAutoFit/>
+          </a:bodyPr>
+          <a:lstStyle/>
+          <a:p>
+            <a:r>
+              <a:rPr sz="800" b="0">
+                <a:solidFill>
+                  <a:srgbClr val="65707D"/>
+                </a:solidFill>
+                <a:latin typeface="Microsoft YaHei"/>
+              </a:rPr>
+              <a:t>纳斯达克100指</a:t>
+            </a:r>
+          </a:p>
+        </p:txBody>
+      </p:sp>
+      <p:sp>
+        <p:nvSpPr>
+          <p:cNvPr id="57" name="Rectangle 56"/>
+          <p:cNvSpPr/>
+          <p:nvPr/>
+        </p:nvSpPr>
+        <p:spPr>
+          <a:xfrm>
+            <a:off x="9646919" y="2578608"/>
+            <a:ext cx="9144" cy="118872"/>
+          </a:xfrm>
+          <a:prstGeom prst="rect">
+            <a:avLst/>
+          </a:prstGeom>
+          <a:solidFill>
+            <a:srgbClr val="DAD5C9"/>
+          </a:solidFill>
+          <a:ln>
+            <a:noFill/>
+          </a:ln>
+        </p:spPr>
+        <p:style>
+          <a:lnRef idx="1">
+            <a:schemeClr val="accent1"/>
+          </a:lnRef>
+          <a:fillRef idx="3">
+            <a:schemeClr val="accent1"/>
+          </a:fillRef>
+          <a:effectRef idx="2">
+            <a:schemeClr val="accent1"/>
+          </a:effectRef>
+          <a:fontRef idx="minor">
+            <a:schemeClr val="lt1"/>
+          </a:fontRef>
+        </p:style>
+        <p:txBody>
+          <a:bodyPr rtlCol="0" anchor="ctr"/>
+          <a:lstStyle/>
+          <a:p>
+            <a:pPr algn="ctr"/>
+          </a:p>
+        </p:txBody>
+      </p:sp>
+      <p:sp>
+        <p:nvSpPr>
+          <p:cNvPr id="58" name="Rectangle 57"/>
+          <p:cNvSpPr/>
+          <p:nvPr/>
+        </p:nvSpPr>
+        <p:spPr>
+          <a:xfrm>
+            <a:off x="9646919" y="2560320"/>
+            <a:ext cx="1325880" cy="146304"/>
           </a:xfrm>
           <a:prstGeom prst="rect">
             <a:avLst/>
@@ -5384,13 +6188,13 @@
       </p:sp>
       <p:sp>
         <p:nvSpPr>
-          <p:cNvPr id="38" name="TextBox 37"/>
-          <p:cNvSpPr txBox="1"/>
-          <p:nvPr/>
-        </p:nvSpPr>
-        <p:spPr>
-          <a:xfrm>
-            <a:off x="6777307" y="2514600"/>
+          <p:cNvPr id="59" name="TextBox 58"/>
+          <p:cNvSpPr txBox="1"/>
+          <p:nvPr/>
+        </p:nvSpPr>
+        <p:spPr>
+          <a:xfrm>
+            <a:off x="11018519" y="2514600"/>
             <a:ext cx="502920" cy="201168"/>
           </a:xfrm>
           <a:prstGeom prst="rect">
@@ -5411,20 +6215,20 @@
                 </a:solidFill>
                 <a:latin typeface="Microsoft YaHei"/>
               </a:rPr>
-              <a:t>0.70%</a:t>
-            </a:r>
-          </a:p>
-        </p:txBody>
-      </p:sp>
-      <p:sp>
-        <p:nvSpPr>
-          <p:cNvPr id="39" name="TextBox 38"/>
-          <p:cNvSpPr txBox="1"/>
-          <p:nvPr/>
-        </p:nvSpPr>
-        <p:spPr>
-          <a:xfrm>
-            <a:off x="4251960" y="2889503"/>
+              <a:t>3.41%</a:t>
+            </a:r>
+          </a:p>
+        </p:txBody>
+      </p:sp>
+      <p:sp>
+        <p:nvSpPr>
+          <p:cNvPr id="60" name="TextBox 59"/>
+          <p:cNvSpPr txBox="1"/>
+          <p:nvPr/>
+        </p:nvSpPr>
+        <p:spPr>
+          <a:xfrm>
+            <a:off x="7863840" y="2889503"/>
             <a:ext cx="1078992" cy="201168"/>
           </a:xfrm>
           <a:prstGeom prst="rect">
@@ -5452,13 +6256,13 @@
       </p:sp>
       <p:sp>
         <p:nvSpPr>
-          <p:cNvPr id="40" name="Rectangle 39"/>
+          <p:cNvPr id="61" name="Rectangle 60"/>
           <p:cNvSpPr/>
           <p:nvPr/>
         </p:nvSpPr>
         <p:spPr>
           <a:xfrm>
-            <a:off x="6035040" y="2962656"/>
+            <a:off x="9646919" y="2962656"/>
             <a:ext cx="9144" cy="118872"/>
           </a:xfrm>
           <a:prstGeom prst="rect">
@@ -5495,14 +6299,14 @@
       </p:sp>
       <p:sp>
         <p:nvSpPr>
-          <p:cNvPr id="41" name="Rectangle 40"/>
+          <p:cNvPr id="62" name="Rectangle 61"/>
           <p:cNvSpPr/>
           <p:nvPr/>
         </p:nvSpPr>
         <p:spPr>
           <a:xfrm>
-            <a:off x="5098198" y="2944368"/>
-            <a:ext cx="936841" cy="146304"/>
+            <a:off x="9047949" y="2944368"/>
+            <a:ext cx="598970" cy="146304"/>
           </a:xfrm>
           <a:prstGeom prst="rect">
             <a:avLst/>
@@ -5538,13 +6342,13 @@
       </p:sp>
       <p:sp>
         <p:nvSpPr>
-          <p:cNvPr id="42" name="TextBox 41"/>
-          <p:cNvSpPr txBox="1"/>
-          <p:nvPr/>
-        </p:nvSpPr>
-        <p:spPr>
-          <a:xfrm>
-            <a:off x="6080760" y="2898648"/>
+          <p:cNvPr id="63" name="TextBox 62"/>
+          <p:cNvSpPr txBox="1"/>
+          <p:nvPr/>
+        </p:nvSpPr>
+        <p:spPr>
+          <a:xfrm>
+            <a:off x="9692640" y="2898648"/>
             <a:ext cx="502920" cy="201168"/>
           </a:xfrm>
           <a:prstGeom prst="rect">
@@ -5565,20 +6369,20 @@
                 </a:solidFill>
                 <a:latin typeface="Microsoft YaHei"/>
               </a:rPr>
-              <a:t>-0.95%</a:t>
-            </a:r>
-          </a:p>
-        </p:txBody>
-      </p:sp>
-      <p:sp>
-        <p:nvSpPr>
-          <p:cNvPr id="43" name="TextBox 42"/>
-          <p:cNvSpPr txBox="1"/>
-          <p:nvPr/>
-        </p:nvSpPr>
-        <p:spPr>
-          <a:xfrm>
-            <a:off x="4251960" y="3273551"/>
+              <a:t>-1.54%</a:t>
+            </a:r>
+          </a:p>
+        </p:txBody>
+      </p:sp>
+      <p:sp>
+        <p:nvSpPr>
+          <p:cNvPr id="64" name="TextBox 63"/>
+          <p:cNvSpPr txBox="1"/>
+          <p:nvPr/>
+        </p:nvSpPr>
+        <p:spPr>
+          <a:xfrm>
+            <a:off x="7863840" y="3273551"/>
             <a:ext cx="1078992" cy="201168"/>
           </a:xfrm>
           <a:prstGeom prst="rect">
@@ -5606,13 +6410,13 @@
       </p:sp>
       <p:sp>
         <p:nvSpPr>
-          <p:cNvPr id="44" name="Rectangle 43"/>
+          <p:cNvPr id="65" name="Rectangle 64"/>
           <p:cNvSpPr/>
           <p:nvPr/>
         </p:nvSpPr>
         <p:spPr>
           <a:xfrm>
-            <a:off x="6035040" y="3346703"/>
+            <a:off x="9646919" y="3346703"/>
             <a:ext cx="9144" cy="118872"/>
           </a:xfrm>
           <a:prstGeom prst="rect">
@@ -5649,356 +6453,14 @@
       </p:sp>
       <p:sp>
         <p:nvSpPr>
-          <p:cNvPr id="45" name="Rectangle 44"/>
+          <p:cNvPr id="66" name="Rectangle 65"/>
           <p:cNvSpPr/>
           <p:nvPr/>
         </p:nvSpPr>
         <p:spPr>
           <a:xfrm>
-            <a:off x="4841830" y="3328415"/>
-            <a:ext cx="1193209" cy="146304"/>
-          </a:xfrm>
-          <a:prstGeom prst="rect">
-            <a:avLst/>
-          </a:prstGeom>
-          <a:solidFill>
-            <a:srgbClr val="BF4040"/>
-          </a:solidFill>
-          <a:ln>
-            <a:noFill/>
-          </a:ln>
-        </p:spPr>
-        <p:style>
-          <a:lnRef idx="1">
-            <a:schemeClr val="accent1"/>
-          </a:lnRef>
-          <a:fillRef idx="3">
-            <a:schemeClr val="accent1"/>
-          </a:fillRef>
-          <a:effectRef idx="2">
-            <a:schemeClr val="accent1"/>
-          </a:effectRef>
-          <a:fontRef idx="minor">
-            <a:schemeClr val="lt1"/>
-          </a:fontRef>
-        </p:style>
-        <p:txBody>
-          <a:bodyPr rtlCol="0" anchor="ctr"/>
-          <a:lstStyle/>
-          <a:p>
-            <a:pPr algn="ctr"/>
-          </a:p>
-        </p:txBody>
-      </p:sp>
-      <p:sp>
-        <p:nvSpPr>
-          <p:cNvPr id="46" name="TextBox 45"/>
-          <p:cNvSpPr txBox="1"/>
-          <p:nvPr/>
-        </p:nvSpPr>
-        <p:spPr>
-          <a:xfrm>
-            <a:off x="6080760" y="3282696"/>
-            <a:ext cx="502920" cy="201168"/>
-          </a:xfrm>
-          <a:prstGeom prst="rect">
-            <a:avLst/>
-          </a:prstGeom>
-          <a:noFill/>
-        </p:spPr>
-        <p:txBody>
-          <a:bodyPr wrap="none" lIns="18288" rIns="18288" tIns="18288" bIns="18288">
-            <a:spAutoFit/>
-          </a:bodyPr>
-          <a:lstStyle/>
-          <a:p>
-            <a:r>
-              <a:rPr sz="800" b="0">
-                <a:solidFill>
-                  <a:srgbClr val="1A2026"/>
-                </a:solidFill>
-                <a:latin typeface="Microsoft YaHei"/>
-              </a:rPr>
-              <a:t>-1.21%</a:t>
-            </a:r>
-          </a:p>
-        </p:txBody>
-      </p:sp>
-      <p:sp>
-        <p:nvSpPr>
-          <p:cNvPr id="47" name="TextBox 46"/>
-          <p:cNvSpPr txBox="1"/>
-          <p:nvPr/>
-        </p:nvSpPr>
-        <p:spPr>
-          <a:xfrm>
-            <a:off x="7863840" y="1371600"/>
-            <a:ext cx="3383280" cy="219456"/>
-          </a:xfrm>
-          <a:prstGeom prst="rect">
-            <a:avLst/>
-          </a:prstGeom>
-          <a:noFill/>
-        </p:spPr>
-        <p:txBody>
-          <a:bodyPr wrap="none" lIns="18288" rIns="18288" tIns="18288" bIns="18288">
-            <a:spAutoFit/>
-          </a:bodyPr>
-          <a:lstStyle/>
-          <a:p>
-            <a:r>
-              <a:rPr sz="1100" b="1">
-                <a:solidFill>
-                  <a:srgbClr val="1A2026"/>
-                </a:solidFill>
-                <a:latin typeface="Microsoft YaHei"/>
-              </a:rPr>
-              <a:t>近1个月收益</a:t>
-            </a:r>
-          </a:p>
-        </p:txBody>
-      </p:sp>
-      <p:sp>
-        <p:nvSpPr>
-          <p:cNvPr id="48" name="TextBox 47"/>
-          <p:cNvSpPr txBox="1"/>
-          <p:nvPr/>
-        </p:nvSpPr>
-        <p:spPr>
-          <a:xfrm>
-            <a:off x="7863840" y="1737360"/>
-            <a:ext cx="1078992" cy="201168"/>
-          </a:xfrm>
-          <a:prstGeom prst="rect">
-            <a:avLst/>
-          </a:prstGeom>
-          <a:noFill/>
-        </p:spPr>
-        <p:txBody>
-          <a:bodyPr wrap="none" lIns="18288" rIns="18288" tIns="18288" bIns="18288">
-            <a:spAutoFit/>
-          </a:bodyPr>
-          <a:lstStyle/>
-          <a:p>
-            <a:r>
-              <a:rPr sz="800" b="0">
-                <a:solidFill>
-                  <a:srgbClr val="65707D"/>
-                </a:solidFill>
-                <a:latin typeface="Microsoft YaHei"/>
-              </a:rPr>
-              <a:t>华夏沪深300E</a:t>
-            </a:r>
-          </a:p>
-        </p:txBody>
-      </p:sp>
-      <p:sp>
-        <p:nvSpPr>
-          <p:cNvPr id="49" name="Rectangle 48"/>
-          <p:cNvSpPr/>
-          <p:nvPr/>
-        </p:nvSpPr>
-        <p:spPr>
-          <a:xfrm>
-            <a:off x="9646919" y="1810512"/>
-            <a:ext cx="9144" cy="118872"/>
-          </a:xfrm>
-          <a:prstGeom prst="rect">
-            <a:avLst/>
-          </a:prstGeom>
-          <a:solidFill>
-            <a:srgbClr val="DAD5C9"/>
-          </a:solidFill>
-          <a:ln>
-            <a:noFill/>
-          </a:ln>
-        </p:spPr>
-        <p:style>
-          <a:lnRef idx="1">
-            <a:schemeClr val="accent1"/>
-          </a:lnRef>
-          <a:fillRef idx="3">
-            <a:schemeClr val="accent1"/>
-          </a:fillRef>
-          <a:effectRef idx="2">
-            <a:schemeClr val="accent1"/>
-          </a:effectRef>
-          <a:fontRef idx="minor">
-            <a:schemeClr val="lt1"/>
-          </a:fontRef>
-        </p:style>
-        <p:txBody>
-          <a:bodyPr rtlCol="0" anchor="ctr"/>
-          <a:lstStyle/>
-          <a:p>
-            <a:pPr algn="ctr"/>
-          </a:p>
-        </p:txBody>
-      </p:sp>
-      <p:sp>
-        <p:nvSpPr>
-          <p:cNvPr id="50" name="Rectangle 49"/>
-          <p:cNvSpPr/>
-          <p:nvPr/>
-        </p:nvSpPr>
-        <p:spPr>
-          <a:xfrm>
-            <a:off x="8681939" y="1792224"/>
-            <a:ext cx="964980" cy="146304"/>
-          </a:xfrm>
-          <a:prstGeom prst="rect">
-            <a:avLst/>
-          </a:prstGeom>
-          <a:solidFill>
-            <a:srgbClr val="BF4040"/>
-          </a:solidFill>
-          <a:ln>
-            <a:noFill/>
-          </a:ln>
-        </p:spPr>
-        <p:style>
-          <a:lnRef idx="1">
-            <a:schemeClr val="accent1"/>
-          </a:lnRef>
-          <a:fillRef idx="3">
-            <a:schemeClr val="accent1"/>
-          </a:fillRef>
-          <a:effectRef idx="2">
-            <a:schemeClr val="accent1"/>
-          </a:effectRef>
-          <a:fontRef idx="minor">
-            <a:schemeClr val="lt1"/>
-          </a:fontRef>
-        </p:style>
-        <p:txBody>
-          <a:bodyPr rtlCol="0" anchor="ctr"/>
-          <a:lstStyle/>
-          <a:p>
-            <a:pPr algn="ctr"/>
-          </a:p>
-        </p:txBody>
-      </p:sp>
-      <p:sp>
-        <p:nvSpPr>
-          <p:cNvPr id="51" name="TextBox 50"/>
-          <p:cNvSpPr txBox="1"/>
-          <p:nvPr/>
-        </p:nvSpPr>
-        <p:spPr>
-          <a:xfrm>
-            <a:off x="9692640" y="1746504"/>
-            <a:ext cx="502920" cy="201168"/>
-          </a:xfrm>
-          <a:prstGeom prst="rect">
-            <a:avLst/>
-          </a:prstGeom>
-          <a:noFill/>
-        </p:spPr>
-        <p:txBody>
-          <a:bodyPr wrap="none" lIns="18288" rIns="18288" tIns="18288" bIns="18288">
-            <a:spAutoFit/>
-          </a:bodyPr>
-          <a:lstStyle/>
-          <a:p>
-            <a:r>
-              <a:rPr sz="800" b="0">
-                <a:solidFill>
-                  <a:srgbClr val="1A2026"/>
-                </a:solidFill>
-                <a:latin typeface="Microsoft YaHei"/>
-              </a:rPr>
-              <a:t>-1.42%</a:t>
-            </a:r>
-          </a:p>
-        </p:txBody>
-      </p:sp>
-      <p:sp>
-        <p:nvSpPr>
-          <p:cNvPr id="52" name="TextBox 51"/>
-          <p:cNvSpPr txBox="1"/>
-          <p:nvPr/>
-        </p:nvSpPr>
-        <p:spPr>
-          <a:xfrm>
-            <a:off x="7863840" y="2121408"/>
-            <a:ext cx="1078992" cy="201168"/>
-          </a:xfrm>
-          <a:prstGeom prst="rect">
-            <a:avLst/>
-          </a:prstGeom>
-          <a:noFill/>
-        </p:spPr>
-        <p:txBody>
-          <a:bodyPr wrap="none" lIns="18288" rIns="18288" tIns="18288" bIns="18288">
-            <a:spAutoFit/>
-          </a:bodyPr>
-          <a:lstStyle/>
-          <a:p>
-            <a:r>
-              <a:rPr sz="800" b="0">
-                <a:solidFill>
-                  <a:srgbClr val="65707D"/>
-                </a:solidFill>
-                <a:latin typeface="Microsoft YaHei"/>
-              </a:rPr>
-              <a:t>富国红利精选QD</a:t>
-            </a:r>
-          </a:p>
-        </p:txBody>
-      </p:sp>
-      <p:sp>
-        <p:nvSpPr>
-          <p:cNvPr id="53" name="Rectangle 52"/>
-          <p:cNvSpPr/>
-          <p:nvPr/>
-        </p:nvSpPr>
-        <p:spPr>
-          <a:xfrm>
-            <a:off x="9646919" y="2194560"/>
-            <a:ext cx="9144" cy="118872"/>
-          </a:xfrm>
-          <a:prstGeom prst="rect">
-            <a:avLst/>
-          </a:prstGeom>
-          <a:solidFill>
-            <a:srgbClr val="DAD5C9"/>
-          </a:solidFill>
-          <a:ln>
-            <a:noFill/>
-          </a:ln>
-        </p:spPr>
-        <p:style>
-          <a:lnRef idx="1">
-            <a:schemeClr val="accent1"/>
-          </a:lnRef>
-          <a:fillRef idx="3">
-            <a:schemeClr val="accent1"/>
-          </a:fillRef>
-          <a:effectRef idx="2">
-            <a:schemeClr val="accent1"/>
-          </a:effectRef>
-          <a:fontRef idx="minor">
-            <a:schemeClr val="lt1"/>
-          </a:fontRef>
-        </p:style>
-        <p:txBody>
-          <a:bodyPr rtlCol="0" anchor="ctr"/>
-          <a:lstStyle/>
-          <a:p>
-            <a:pPr algn="ctr"/>
-          </a:p>
-        </p:txBody>
-      </p:sp>
-      <p:sp>
-        <p:nvSpPr>
-          <p:cNvPr id="54" name="Rectangle 53"/>
-          <p:cNvSpPr/>
-          <p:nvPr/>
-        </p:nvSpPr>
-        <p:spPr>
-          <a:xfrm>
-            <a:off x="9646919" y="2176272"/>
-            <a:ext cx="551568" cy="146304"/>
+            <a:off x="9646919" y="3328415"/>
+            <a:ext cx="145386" cy="146304"/>
           </a:xfrm>
           <a:prstGeom prst="rect">
             <a:avLst/>
@@ -6034,13 +6496,13 @@
       </p:sp>
       <p:sp>
         <p:nvSpPr>
-          <p:cNvPr id="55" name="TextBox 54"/>
-          <p:cNvSpPr txBox="1"/>
-          <p:nvPr/>
-        </p:nvSpPr>
-        <p:spPr>
-          <a:xfrm>
-            <a:off x="10244208" y="2130552"/>
+          <p:cNvPr id="67" name="TextBox 66"/>
+          <p:cNvSpPr txBox="1"/>
+          <p:nvPr/>
+        </p:nvSpPr>
+        <p:spPr>
+          <a:xfrm>
+            <a:off x="9838026" y="3282696"/>
             <a:ext cx="502920" cy="201168"/>
           </a:xfrm>
           <a:prstGeom prst="rect">
@@ -6061,469 +6523,7 @@
                 </a:solidFill>
                 <a:latin typeface="Microsoft YaHei"/>
               </a:rPr>
-              <a:t>0.81%</a:t>
-            </a:r>
-          </a:p>
-        </p:txBody>
-      </p:sp>
-      <p:sp>
-        <p:nvSpPr>
-          <p:cNvPr id="56" name="TextBox 55"/>
-          <p:cNvSpPr txBox="1"/>
-          <p:nvPr/>
-        </p:nvSpPr>
-        <p:spPr>
-          <a:xfrm>
-            <a:off x="7863840" y="2505456"/>
-            <a:ext cx="1078992" cy="201168"/>
-          </a:xfrm>
-          <a:prstGeom prst="rect">
-            <a:avLst/>
-          </a:prstGeom>
-          <a:noFill/>
-        </p:spPr>
-        <p:txBody>
-          <a:bodyPr wrap="none" lIns="18288" rIns="18288" tIns="18288" bIns="18288">
-            <a:spAutoFit/>
-          </a:bodyPr>
-          <a:lstStyle/>
-          <a:p>
-            <a:r>
-              <a:rPr sz="800" b="0">
-                <a:solidFill>
-                  <a:srgbClr val="65707D"/>
-                </a:solidFill>
-                <a:latin typeface="Microsoft YaHei"/>
-              </a:rPr>
-              <a:t>纳斯达克100指</a:t>
-            </a:r>
-          </a:p>
-        </p:txBody>
-      </p:sp>
-      <p:sp>
-        <p:nvSpPr>
-          <p:cNvPr id="57" name="Rectangle 56"/>
-          <p:cNvSpPr/>
-          <p:nvPr/>
-        </p:nvSpPr>
-        <p:spPr>
-          <a:xfrm>
-            <a:off x="9646919" y="2578608"/>
-            <a:ext cx="9144" cy="118872"/>
-          </a:xfrm>
-          <a:prstGeom prst="rect">
-            <a:avLst/>
-          </a:prstGeom>
-          <a:solidFill>
-            <a:srgbClr val="DAD5C9"/>
-          </a:solidFill>
-          <a:ln>
-            <a:noFill/>
-          </a:ln>
-        </p:spPr>
-        <p:style>
-          <a:lnRef idx="1">
-            <a:schemeClr val="accent1"/>
-          </a:lnRef>
-          <a:fillRef idx="3">
-            <a:schemeClr val="accent1"/>
-          </a:fillRef>
-          <a:effectRef idx="2">
-            <a:schemeClr val="accent1"/>
-          </a:effectRef>
-          <a:fontRef idx="minor">
-            <a:schemeClr val="lt1"/>
-          </a:fontRef>
-        </p:style>
-        <p:txBody>
-          <a:bodyPr rtlCol="0" anchor="ctr"/>
-          <a:lstStyle/>
-          <a:p>
-            <a:pPr algn="ctr"/>
-          </a:p>
-        </p:txBody>
-      </p:sp>
-      <p:sp>
-        <p:nvSpPr>
-          <p:cNvPr id="58" name="Rectangle 57"/>
-          <p:cNvSpPr/>
-          <p:nvPr/>
-        </p:nvSpPr>
-        <p:spPr>
-          <a:xfrm>
-            <a:off x="9646919" y="2560320"/>
-            <a:ext cx="650723" cy="146304"/>
-          </a:xfrm>
-          <a:prstGeom prst="rect">
-            <a:avLst/>
-          </a:prstGeom>
-          <a:solidFill>
-            <a:srgbClr val="198974"/>
-          </a:solidFill>
-          <a:ln>
-            <a:noFill/>
-          </a:ln>
-        </p:spPr>
-        <p:style>
-          <a:lnRef idx="1">
-            <a:schemeClr val="accent1"/>
-          </a:lnRef>
-          <a:fillRef idx="3">
-            <a:schemeClr val="accent1"/>
-          </a:fillRef>
-          <a:effectRef idx="2">
-            <a:schemeClr val="accent1"/>
-          </a:effectRef>
-          <a:fontRef idx="minor">
-            <a:schemeClr val="lt1"/>
-          </a:fontRef>
-        </p:style>
-        <p:txBody>
-          <a:bodyPr rtlCol="0" anchor="ctr"/>
-          <a:lstStyle/>
-          <a:p>
-            <a:pPr algn="ctr"/>
-          </a:p>
-        </p:txBody>
-      </p:sp>
-      <p:sp>
-        <p:nvSpPr>
-          <p:cNvPr id="59" name="TextBox 58"/>
-          <p:cNvSpPr txBox="1"/>
-          <p:nvPr/>
-        </p:nvSpPr>
-        <p:spPr>
-          <a:xfrm>
-            <a:off x="10343363" y="2514600"/>
-            <a:ext cx="502920" cy="201168"/>
-          </a:xfrm>
-          <a:prstGeom prst="rect">
-            <a:avLst/>
-          </a:prstGeom>
-          <a:noFill/>
-        </p:spPr>
-        <p:txBody>
-          <a:bodyPr wrap="none" lIns="18288" rIns="18288" tIns="18288" bIns="18288">
-            <a:spAutoFit/>
-          </a:bodyPr>
-          <a:lstStyle/>
-          <a:p>
-            <a:r>
-              <a:rPr sz="800" b="0">
-                <a:solidFill>
-                  <a:srgbClr val="1A2026"/>
-                </a:solidFill>
-                <a:latin typeface="Microsoft YaHei"/>
-              </a:rPr>
-              <a:t>0.96%</a:t>
-            </a:r>
-          </a:p>
-        </p:txBody>
-      </p:sp>
-      <p:sp>
-        <p:nvSpPr>
-          <p:cNvPr id="60" name="TextBox 59"/>
-          <p:cNvSpPr txBox="1"/>
-          <p:nvPr/>
-        </p:nvSpPr>
-        <p:spPr>
-          <a:xfrm>
-            <a:off x="7863840" y="2889503"/>
-            <a:ext cx="1078992" cy="201168"/>
-          </a:xfrm>
-          <a:prstGeom prst="rect">
-            <a:avLst/>
-          </a:prstGeom>
-          <a:noFill/>
-        </p:spPr>
-        <p:txBody>
-          <a:bodyPr wrap="none" lIns="18288" rIns="18288" tIns="18288" bIns="18288">
-            <a:spAutoFit/>
-          </a:bodyPr>
-          <a:lstStyle/>
-          <a:p>
-            <a:r>
-              <a:rPr sz="800" b="0">
-                <a:solidFill>
-                  <a:srgbClr val="65707D"/>
-                </a:solidFill>
-                <a:latin typeface="Microsoft YaHei"/>
-              </a:rPr>
-              <a:t>兴全安泰积极养老</a:t>
-            </a:r>
-          </a:p>
-        </p:txBody>
-      </p:sp>
-      <p:sp>
-        <p:nvSpPr>
-          <p:cNvPr id="61" name="Rectangle 60"/>
-          <p:cNvSpPr/>
-          <p:nvPr/>
-        </p:nvSpPr>
-        <p:spPr>
-          <a:xfrm>
-            <a:off x="9646919" y="2962656"/>
-            <a:ext cx="9144" cy="118872"/>
-          </a:xfrm>
-          <a:prstGeom prst="rect">
-            <a:avLst/>
-          </a:prstGeom>
-          <a:solidFill>
-            <a:srgbClr val="DAD5C9"/>
-          </a:solidFill>
-          <a:ln>
-            <a:noFill/>
-          </a:ln>
-        </p:spPr>
-        <p:style>
-          <a:lnRef idx="1">
-            <a:schemeClr val="accent1"/>
-          </a:lnRef>
-          <a:fillRef idx="3">
-            <a:schemeClr val="accent1"/>
-          </a:fillRef>
-          <a:effectRef idx="2">
-            <a:schemeClr val="accent1"/>
-          </a:effectRef>
-          <a:fontRef idx="minor">
-            <a:schemeClr val="lt1"/>
-          </a:fontRef>
-        </p:style>
-        <p:txBody>
-          <a:bodyPr rtlCol="0" anchor="ctr"/>
-          <a:lstStyle/>
-          <a:p>
-            <a:pPr algn="ctr"/>
-          </a:p>
-        </p:txBody>
-      </p:sp>
-      <p:sp>
-        <p:nvSpPr>
-          <p:cNvPr id="62" name="Rectangle 61"/>
-          <p:cNvSpPr/>
-          <p:nvPr/>
-        </p:nvSpPr>
-        <p:spPr>
-          <a:xfrm>
-            <a:off x="8321040" y="2944368"/>
-            <a:ext cx="1325880" cy="146304"/>
-          </a:xfrm>
-          <a:prstGeom prst="rect">
-            <a:avLst/>
-          </a:prstGeom>
-          <a:solidFill>
-            <a:srgbClr val="BF4040"/>
-          </a:solidFill>
-          <a:ln>
-            <a:noFill/>
-          </a:ln>
-        </p:spPr>
-        <p:style>
-          <a:lnRef idx="1">
-            <a:schemeClr val="accent1"/>
-          </a:lnRef>
-          <a:fillRef idx="3">
-            <a:schemeClr val="accent1"/>
-          </a:fillRef>
-          <a:effectRef idx="2">
-            <a:schemeClr val="accent1"/>
-          </a:effectRef>
-          <a:fontRef idx="minor">
-            <a:schemeClr val="lt1"/>
-          </a:fontRef>
-        </p:style>
-        <p:txBody>
-          <a:bodyPr rtlCol="0" anchor="ctr"/>
-          <a:lstStyle/>
-          <a:p>
-            <a:pPr algn="ctr"/>
-          </a:p>
-        </p:txBody>
-      </p:sp>
-      <p:sp>
-        <p:nvSpPr>
-          <p:cNvPr id="63" name="TextBox 62"/>
-          <p:cNvSpPr txBox="1"/>
-          <p:nvPr/>
-        </p:nvSpPr>
-        <p:spPr>
-          <a:xfrm>
-            <a:off x="9692640" y="2898648"/>
-            <a:ext cx="502920" cy="201168"/>
-          </a:xfrm>
-          <a:prstGeom prst="rect">
-            <a:avLst/>
-          </a:prstGeom>
-          <a:noFill/>
-        </p:spPr>
-        <p:txBody>
-          <a:bodyPr wrap="none" lIns="18288" rIns="18288" tIns="18288" bIns="18288">
-            <a:spAutoFit/>
-          </a:bodyPr>
-          <a:lstStyle/>
-          <a:p>
-            <a:r>
-              <a:rPr sz="800" b="0">
-                <a:solidFill>
-                  <a:srgbClr val="1A2026"/>
-                </a:solidFill>
-                <a:latin typeface="Microsoft YaHei"/>
-              </a:rPr>
-              <a:t>-1.96%</a:t>
-            </a:r>
-          </a:p>
-        </p:txBody>
-      </p:sp>
-      <p:sp>
-        <p:nvSpPr>
-          <p:cNvPr id="64" name="TextBox 63"/>
-          <p:cNvSpPr txBox="1"/>
-          <p:nvPr/>
-        </p:nvSpPr>
-        <p:spPr>
-          <a:xfrm>
-            <a:off x="7863840" y="3273551"/>
-            <a:ext cx="1078992" cy="201168"/>
-          </a:xfrm>
-          <a:prstGeom prst="rect">
-            <a:avLst/>
-          </a:prstGeom>
-          <a:noFill/>
-        </p:spPr>
-        <p:txBody>
-          <a:bodyPr wrap="none" lIns="18288" rIns="18288" tIns="18288" bIns="18288">
-            <a:spAutoFit/>
-          </a:bodyPr>
-          <a:lstStyle/>
-          <a:p>
-            <a:r>
-              <a:rPr sz="800" b="0">
-                <a:solidFill>
-                  <a:srgbClr val="65707D"/>
-                </a:solidFill>
-                <a:latin typeface="Microsoft YaHei"/>
-              </a:rPr>
-              <a:t>易方达全球优质企</a:t>
-            </a:r>
-          </a:p>
-        </p:txBody>
-      </p:sp>
-      <p:sp>
-        <p:nvSpPr>
-          <p:cNvPr id="65" name="Rectangle 64"/>
-          <p:cNvSpPr/>
-          <p:nvPr/>
-        </p:nvSpPr>
-        <p:spPr>
-          <a:xfrm>
-            <a:off x="9646919" y="3346703"/>
-            <a:ext cx="9144" cy="118872"/>
-          </a:xfrm>
-          <a:prstGeom prst="rect">
-            <a:avLst/>
-          </a:prstGeom>
-          <a:solidFill>
-            <a:srgbClr val="DAD5C9"/>
-          </a:solidFill>
-          <a:ln>
-            <a:noFill/>
-          </a:ln>
-        </p:spPr>
-        <p:style>
-          <a:lnRef idx="1">
-            <a:schemeClr val="accent1"/>
-          </a:lnRef>
-          <a:fillRef idx="3">
-            <a:schemeClr val="accent1"/>
-          </a:fillRef>
-          <a:effectRef idx="2">
-            <a:schemeClr val="accent1"/>
-          </a:effectRef>
-          <a:fontRef idx="minor">
-            <a:schemeClr val="lt1"/>
-          </a:fontRef>
-        </p:style>
-        <p:txBody>
-          <a:bodyPr rtlCol="0" anchor="ctr"/>
-          <a:lstStyle/>
-          <a:p>
-            <a:pPr algn="ctr"/>
-          </a:p>
-        </p:txBody>
-      </p:sp>
-      <p:sp>
-        <p:nvSpPr>
-          <p:cNvPr id="66" name="Rectangle 65"/>
-          <p:cNvSpPr/>
-          <p:nvPr/>
-        </p:nvSpPr>
-        <p:spPr>
-          <a:xfrm>
-            <a:off x="9167020" y="3328415"/>
-            <a:ext cx="479899" cy="146304"/>
-          </a:xfrm>
-          <a:prstGeom prst="rect">
-            <a:avLst/>
-          </a:prstGeom>
-          <a:solidFill>
-            <a:srgbClr val="BF4040"/>
-          </a:solidFill>
-          <a:ln>
-            <a:noFill/>
-          </a:ln>
-        </p:spPr>
-        <p:style>
-          <a:lnRef idx="1">
-            <a:schemeClr val="accent1"/>
-          </a:lnRef>
-          <a:fillRef idx="3">
-            <a:schemeClr val="accent1"/>
-          </a:fillRef>
-          <a:effectRef idx="2">
-            <a:schemeClr val="accent1"/>
-          </a:effectRef>
-          <a:fontRef idx="minor">
-            <a:schemeClr val="lt1"/>
-          </a:fontRef>
-        </p:style>
-        <p:txBody>
-          <a:bodyPr rtlCol="0" anchor="ctr"/>
-          <a:lstStyle/>
-          <a:p>
-            <a:pPr algn="ctr"/>
-          </a:p>
-        </p:txBody>
-      </p:sp>
-      <p:sp>
-        <p:nvSpPr>
-          <p:cNvPr id="67" name="TextBox 66"/>
-          <p:cNvSpPr txBox="1"/>
-          <p:nvPr/>
-        </p:nvSpPr>
-        <p:spPr>
-          <a:xfrm>
-            <a:off x="9692640" y="3282696"/>
-            <a:ext cx="502920" cy="201168"/>
-          </a:xfrm>
-          <a:prstGeom prst="rect">
-            <a:avLst/>
-          </a:prstGeom>
-          <a:noFill/>
-        </p:spPr>
-        <p:txBody>
-          <a:bodyPr wrap="none" lIns="18288" rIns="18288" tIns="18288" bIns="18288">
-            <a:spAutoFit/>
-          </a:bodyPr>
-          <a:lstStyle/>
-          <a:p>
-            <a:r>
-              <a:rPr sz="800" b="0">
-                <a:solidFill>
-                  <a:srgbClr val="1A2026"/>
-                </a:solidFill>
-                <a:latin typeface="Microsoft YaHei"/>
-              </a:rPr>
-              <a:t>-0.71%</a:t>
+              <a:t>0.37%</a:t>
             </a:r>
           </a:p>
         </p:txBody>
@@ -6761,7 +6761,7 @@
                 </a:solidFill>
                 <a:latin typeface="Microsoft YaHei"/>
               </a:rPr>
-              <a:t>1.7387</a:t>
+              <a:t>1.7409</a:t>
             </a:r>
           </a:p>
         </p:txBody>
@@ -6795,7 +6795,7 @@
                 </a:solidFill>
                 <a:latin typeface="Microsoft YaHei"/>
               </a:rPr>
-              <a:t>2026-09-21</a:t>
+              <a:t>2026-09-22</a:t>
             </a:r>
           </a:p>
         </p:txBody>
@@ -6897,7 +6897,7 @@
                 </a:solidFill>
                 <a:latin typeface="Microsoft YaHei"/>
               </a:rPr>
-              <a:t>1.8715</a:t>
+              <a:t>1.8713</a:t>
             </a:r>
           </a:p>
         </p:txBody>
@@ -6931,7 +6931,7 @@
                 </a:solidFill>
                 <a:latin typeface="Microsoft YaHei"/>
               </a:rPr>
-              <a:t>2026-09-18</a:t>
+              <a:t>2026-09-21</a:t>
             </a:r>
           </a:p>
         </p:txBody>
@@ -7033,7 +7033,7 @@
                 </a:solidFill>
                 <a:latin typeface="Microsoft YaHei"/>
               </a:rPr>
-              <a:t>2.0305</a:t>
+              <a:t>2.0852</a:t>
             </a:r>
           </a:p>
         </p:txBody>
@@ -7067,7 +7067,7 @@
                 </a:solidFill>
                 <a:latin typeface="Microsoft YaHei"/>
               </a:rPr>
-              <a:t>2026-09-18</a:t>
+              <a:t>2026-09-21</a:t>
             </a:r>
           </a:p>
         </p:txBody>
@@ -7169,7 +7169,7 @@
                 </a:solidFill>
                 <a:latin typeface="Microsoft YaHei"/>
               </a:rPr>
-              <a:t>1.2235</a:t>
+              <a:t>1.2347</a:t>
             </a:r>
           </a:p>
         </p:txBody>
@@ -7203,7 +7203,7 @@
                 </a:solidFill>
                 <a:latin typeface="Microsoft YaHei"/>
               </a:rPr>
-              <a:t>2026-09-17</a:t>
+              <a:t>2026-09-18</a:t>
             </a:r>
           </a:p>
         </p:txBody>
@@ -7305,7 +7305,7 @@
                 </a:solidFill>
                 <a:latin typeface="Microsoft YaHei"/>
               </a:rPr>
-              <a:t>2.0063</a:t>
+              <a:t>2.0420</a:t>
             </a:r>
           </a:p>
         </p:txBody>
@@ -7339,7 +7339,7 @@
                 </a:solidFill>
                 <a:latin typeface="Microsoft YaHei"/>
               </a:rPr>
-              <a:t>2026-09-18</a:t>
+              <a:t>2026-09-21</a:t>
             </a:r>
           </a:p>
         </p:txBody>
@@ -7737,7 +7737,7 @@
         <p:spPr>
           <a:xfrm>
             <a:off x="8549640" y="1737360"/>
-            <a:ext cx="1290166" cy="201168"/>
+            <a:ext cx="1285215" cy="201168"/>
           </a:xfrm>
           <a:prstGeom prst="rect">
             <a:avLst/>
@@ -7800,7 +7800,7 @@
                 </a:solidFill>
                 <a:latin typeface="Microsoft YaHei"/>
               </a:rPr>
-              <a:t>20.15%</a:t>
+              <a:t>20.14%</a:t>
             </a:r>
           </a:p>
         </p:txBody>
@@ -7959,7 +7959,7 @@
         <p:spPr>
           <a:xfrm>
             <a:off x="8549640" y="2331720"/>
-            <a:ext cx="794802" cy="201168"/>
+            <a:ext cx="791491" cy="201168"/>
           </a:xfrm>
           <a:prstGeom prst="rect">
             <a:avLst/>
@@ -8022,7 +8022,7 @@
                 </a:solidFill>
                 <a:latin typeface="Microsoft YaHei"/>
               </a:rPr>
-              <a:t>12.42%</a:t>
+              <a:t>12.41%</a:t>
             </a:r>
           </a:p>
         </p:txBody>
@@ -8181,7 +8181,7 @@
         <p:spPr>
           <a:xfrm>
             <a:off x="8549640" y="2926080"/>
-            <a:ext cx="1343894" cy="201168"/>
+            <a:ext cx="1369067" cy="201168"/>
           </a:xfrm>
           <a:prstGeom prst="rect">
             <a:avLst/>
@@ -8244,7 +8244,7 @@
                 </a:solidFill>
                 <a:latin typeface="Microsoft YaHei"/>
               </a:rPr>
-              <a:t>20.99%</a:t>
+              <a:t>21.46%</a:t>
             </a:r>
           </a:p>
         </p:txBody>
@@ -8403,7 +8403,7 @@
         <p:spPr>
           <a:xfrm>
             <a:off x="8549640" y="3520440"/>
-            <a:ext cx="980757" cy="201168"/>
+            <a:ext cx="979823" cy="201168"/>
           </a:xfrm>
           <a:prstGeom prst="rect">
             <a:avLst/>
@@ -8466,7 +8466,7 @@
                 </a:solidFill>
                 <a:latin typeface="Microsoft YaHei"/>
               </a:rPr>
-              <a:t>15.32%</a:t>
+              <a:t>15.36%</a:t>
             </a:r>
           </a:p>
         </p:txBody>
@@ -8688,7 +8688,7 @@
                 </a:solidFill>
                 <a:latin typeface="Microsoft YaHei"/>
               </a:rPr>
-              <a:t>37.14%</a:t>
+              <a:t>37.26%</a:t>
             </a:r>
           </a:p>
         </p:txBody>
@@ -9108,7 +9108,7 @@
                 </a:solidFill>
                 <a:latin typeface="Microsoft YaHei"/>
               </a:rPr>
-              <a:t>2026-09-21</a:t>
+              <a:t>2026-09-22</a:t>
             </a:r>
           </a:p>
         </p:txBody>
@@ -9244,7 +9244,7 @@
                 </a:solidFill>
                 <a:latin typeface="Microsoft YaHei"/>
               </a:rPr>
-              <a:t>2026-09-18</a:t>
+              <a:t>2026-09-21</a:t>
             </a:r>
           </a:p>
         </p:txBody>
@@ -9380,7 +9380,7 @@
                 </a:solidFill>
                 <a:latin typeface="Microsoft YaHei"/>
               </a:rPr>
-              <a:t>2026-09-18</a:t>
+              <a:t>2026-09-21</a:t>
             </a:r>
           </a:p>
         </p:txBody>
@@ -9516,7 +9516,7 @@
                 </a:solidFill>
                 <a:latin typeface="Microsoft YaHei"/>
               </a:rPr>
-              <a:t>2026-09-17</a:t>
+              <a:t>2026-09-18</a:t>
             </a:r>
           </a:p>
         </p:txBody>
@@ -9652,7 +9652,7 @@
                 </a:solidFill>
                 <a:latin typeface="Microsoft YaHei"/>
               </a:rPr>
-              <a:t>2026-09-18</a:t>
+              <a:t>2026-09-21</a:t>
             </a:r>
           </a:p>
         </p:txBody>

</xml_diff>